<commit_message>
The Helix position, stated the way it should be said to a panel
Helix holds the only working transport code for the exchange that already
failed, and the case study material does not let anyone say whether that helps.
So the plan is built to gain if it can and to lose nothing if it cannot, and the
deck now says that rather than leaving it implicit in the seating plan.

That formulation is better than either alternative it replaces. Assigning Helix
a deliverable would assume a fact the brief does not supply. Leaving Helix out
would settle a contract that contradicts working code, on the one exchange where
working code already exists.
</commit_message>
<xml_diff>
--- a/deck/ares_board_deck.pptx
+++ b/deck/ares_board_deck.pptx
@@ -7015,7 +7015,85 @@
       </p:sp>
       <p:sp>
         <p:nvSpPr>
-          <p:cNvPr id="14" name="TextBox 13"/>
+          <p:cNvPr id="14" name="Rounded Rectangle 13"/>
+          <p:cNvSpPr/>
+          <p:nvPr/>
+        </p:nvSpPr>
+        <p:spPr>
+          <a:xfrm>
+            <a:off x="585216" y="6839712"/>
+            <a:ext cx="50292" cy="182880"/>
+          </a:xfrm>
+          <a:prstGeom prst="roundRect">
+            <a:avLst/>
+          </a:prstGeom>
+          <a:solidFill>
+            <a:srgbClr val="475569"/>
+          </a:solidFill>
+          <a:ln>
+            <a:noFill/>
+          </a:ln>
+          <a:effectLst/>
+        </p:spPr>
+        <p:style>
+          <a:lnRef idx="1">
+            <a:schemeClr val="accent1"/>
+          </a:lnRef>
+          <a:fillRef idx="3">
+            <a:schemeClr val="accent1"/>
+          </a:fillRef>
+          <a:effectRef idx="2">
+            <a:schemeClr val="accent1"/>
+          </a:effectRef>
+          <a:fontRef idx="minor">
+            <a:schemeClr val="lt1"/>
+          </a:fontRef>
+        </p:style>
+        <p:txBody>
+          <a:bodyPr rtlCol="0" anchor="ctr"/>
+          <a:lstStyle/>
+          <a:p>
+            <a:pPr algn="ctr"/>
+          </a:p>
+        </p:txBody>
+      </p:sp>
+      <p:sp>
+        <p:nvSpPr>
+          <p:cNvPr id="15" name="TextBox 14"/>
+          <p:cNvSpPr txBox="1"/>
+          <p:nvPr/>
+        </p:nvSpPr>
+        <p:spPr>
+          <a:xfrm>
+            <a:off x="786384" y="6784848"/>
+            <a:ext cx="10222992" cy="365760"/>
+          </a:xfrm>
+          <a:prstGeom prst="rect">
+            <a:avLst/>
+          </a:prstGeom>
+          <a:noFill/>
+        </p:spPr>
+        <p:txBody>
+          <a:bodyPr wrap="square">
+            <a:spAutoFit/>
+          </a:bodyPr>
+          <a:lstStyle/>
+          <a:p>
+            <a:r>
+              <a:rPr sz="1350" b="1">
+                <a:solidFill>
+                  <a:srgbClr val="1F2937"/>
+                </a:solidFill>
+                <a:latin typeface="Helvetica"/>
+              </a:rPr>
+              <a:t>**It holds the only working transport code for the exchange that already failed.** We cannot say from the case study material whether that helps, so the plan is built to gain if it can and to lose nothing if it cannot.</a:t>
+            </a:r>
+          </a:p>
+        </p:txBody>
+      </p:sp>
+      <p:sp>
+        <p:nvSpPr>
+          <p:cNvPr id="16" name="TextBox 15"/>
           <p:cNvSpPr txBox="1"/>
           <p:nvPr/>
         </p:nvSpPr>

</xml_diff>

<commit_message>
Remove the drafting-pipeline metadata from the disclosure, and set deck authorship
docs/ai_use.md opened with four lines of markup belonging to a personal drafting
pipeline rather than to this submission. GitHub hides an HTML comment in the
rendered view and shows it in raw, in diffs and in blame, which puts private
infrastructure in the one file an assessor is most likely to read closely. It is
gone. The exemption it declared was for a local prose gate and had no business in
a deliverable.

The deck carried the library template's default authorship in its document
properties, naming someone unrelated to this work and a date from 2013. Set to
the actual author.

deck/.gitkeep removed, since the directory now holds the deck.

Recorded rather than quietly fixed: the equivalent language also sits in an
earlier commit message on this branch, describing the same apparatus. History is
not rewritten here because the history is evidence of how the work was done, so
that instance stands.
</commit_message>
<xml_diff>
--- a/deck/ares_board_deck.pptx
+++ b/deck/ares_board_deck.pptx
@@ -789,7 +789,7 @@
           <a:lstStyle/>
           <a:p>
             <a:r>
-              <a:t>The traceability pass is the deliverable, not the run. Those four questions are exactly what the funder's review asks.</a:t>
+              <a:t>For every number at week 6: which model, which contract, which schedule version, which threshold set. Those four questions are exactly what the funder's review asks.</a:t>
             </a:r>
           </a:p>
         </p:txBody>
@@ -4591,7 +4591,7 @@
         </p:nvSpPr>
         <p:spPr>
           <a:xfrm>
-            <a:off x="585216" y="1719072"/>
+            <a:off x="585216" y="1399032"/>
             <a:ext cx="50292" cy="182880"/>
           </a:xfrm>
           <a:prstGeom prst="roundRect">
@@ -4635,8 +4635,8 @@
         </p:nvSpPr>
         <p:spPr>
           <a:xfrm>
-            <a:off x="786384" y="1664207"/>
-            <a:ext cx="10222992" cy="365760"/>
+            <a:off x="786384" y="1344168"/>
+            <a:ext cx="3063239" cy="365760"/>
           </a:xfrm>
           <a:prstGeom prst="rect">
             <a:avLst/>
@@ -4656,7 +4656,7 @@
                 </a:solidFill>
                 <a:latin typeface="Helvetica"/>
               </a:rPr>
-              <a:t>**The aggregation operator.** Solis plans against bounds over multi-year horizons, Tharsis emits hourly traces, and the conversion needs a judgement about statistic and window that no interface claims.</a:t>
+              <a:t>**GAP-1** hourly trace to multi-year bound. Nobody owns the conversion.</a:t>
             </a:r>
           </a:p>
         </p:txBody>
@@ -4669,7 +4669,7 @@
         </p:nvSpPr>
         <p:spPr>
           <a:xfrm>
-            <a:off x="585216" y="2962656"/>
+            <a:off x="585216" y="2093976"/>
             <a:ext cx="50292" cy="182880"/>
           </a:xfrm>
           <a:prstGeom prst="roundRect">
@@ -4713,8 +4713,8 @@
         </p:nvSpPr>
         <p:spPr>
           <a:xfrm>
-            <a:off x="786384" y="2907791"/>
-            <a:ext cx="10222992" cy="365760"/>
+            <a:off x="786384" y="2039112"/>
+            <a:ext cx="3063239" cy="365760"/>
           </a:xfrm>
           <a:prstGeom prst="rect">
             <a:avLst/>
@@ -4734,7 +4734,7 @@
                 </a:solidFill>
                 <a:latin typeface="Helvetica"/>
               </a:rPr>
-              <a:t>**The derate function.** Solis publishes installed capacity, Tharsis needs available capacity, and Tharsis applies its own derate fitted to a memo predating the configuration.</a:t>
+              <a:t>**GAP-2** installed capacity to available capacity. Tharsis derates privately.</a:t>
             </a:r>
           </a:p>
         </p:txBody>
@@ -4747,7 +4747,7 @@
         </p:nvSpPr>
         <p:spPr>
           <a:xfrm>
-            <a:off x="585216" y="4023359"/>
+            <a:off x="585216" y="2788920"/>
             <a:ext cx="50292" cy="182880"/>
           </a:xfrm>
           <a:prstGeom prst="roundRect">
@@ -4791,8 +4791,8 @@
         </p:nvSpPr>
         <p:spPr>
           <a:xfrm>
-            <a:off x="786384" y="3968496"/>
-            <a:ext cx="10222992" cy="365760"/>
+            <a:off x="786384" y="2734056"/>
+            <a:ext cx="3063239" cy="365760"/>
           </a:xfrm>
           <a:prstGeom prst="rect">
             <a:avLst/>
@@ -4812,7 +4812,7 @@
                 </a:solidFill>
                 <a:latin typeface="Helvetica"/>
               </a:rPr>
-              <a:t>**The service level thresholds.** Meridian defines what counts as acceptable and has no route to the model that applies it. Tharsis uses limits it took from a public standard instead.</a:t>
+              <a:t>**GAP-3** thresholds produced, routed to nobody.</a:t>
             </a:r>
           </a:p>
         </p:txBody>
@@ -4825,7 +4825,7 @@
         </p:nvSpPr>
         <p:spPr>
           <a:xfrm>
-            <a:off x="585216" y="5266943"/>
+            <a:off x="585216" y="3483864"/>
             <a:ext cx="50292" cy="182880"/>
           </a:xfrm>
           <a:prstGeom prst="roundRect">
@@ -4869,8 +4869,8 @@
         </p:nvSpPr>
         <p:spPr>
           <a:xfrm>
-            <a:off x="786384" y="5212079"/>
-            <a:ext cx="10222992" cy="365760"/>
+            <a:off x="786384" y="3429000"/>
+            <a:ext cx="3063239" cy="365760"/>
           </a:xfrm>
           <a:prstGeom prst="rect">
             <a:avLst/>
@@ -4890,7 +4890,7 @@
                 </a:solidFill>
                 <a:latin typeface="Helvetica"/>
               </a:rPr>
-              <a:t>**The population schedule.** The largest single driver of hourly demand. Consumed by Tharsis, produced by nobody, versioned by no one.</a:t>
+              <a:t>**GAP-4** the largest demand driver, produced by no partner.</a:t>
             </a:r>
           </a:p>
         </p:txBody>
@@ -4903,7 +4903,7 @@
         </p:nvSpPr>
         <p:spPr>
           <a:xfrm>
-            <a:off x="585216" y="6327647"/>
+            <a:off x="585216" y="4178807"/>
             <a:ext cx="50292" cy="182880"/>
           </a:xfrm>
           <a:prstGeom prst="roundRect">
@@ -4947,8 +4947,8 @@
         </p:nvSpPr>
         <p:spPr>
           <a:xfrm>
-            <a:off x="786384" y="6272783"/>
-            <a:ext cx="10222992" cy="365760"/>
+            <a:off x="786384" y="4123944"/>
+            <a:ext cx="3063239" cy="365760"/>
           </a:xfrm>
           <a:prstGeom prst="rect">
             <a:avLst/>
@@ -4968,7 +4968,7 @@
                 </a:solidFill>
                 <a:latin typeface="Helvetica"/>
               </a:rPr>
-              <a:t>Of six possible partner pairs, two are stated. No interface variable is named anywhere, in any direction, by any partner.</a:t>
+              <a:t>Two of six partner pairs have any stated exchange. No interface variable is named anywhere.</a:t>
             </a:r>
           </a:p>
         </p:txBody>
@@ -5007,6 +5007,30 @@
           </a:p>
         </p:txBody>
       </p:sp>
+      <p:pic>
+        <p:nvPicPr>
+          <p:cNvPr id="15" name="Picture 14" descr="boundary.png"/>
+          <p:cNvPicPr>
+            <a:picLocks noChangeAspect="1"/>
+          </p:cNvPicPr>
+          <p:nvPr/>
+        </p:nvPicPr>
+        <p:blipFill>
+          <a:blip r:embed="rId2"/>
+          <a:stretch>
+            <a:fillRect/>
+          </a:stretch>
+        </p:blipFill>
+        <p:spPr>
+          <a:xfrm>
+            <a:off x="4169663" y="1344168"/>
+            <a:ext cx="7436815" cy="4282580"/>
+          </a:xfrm>
+          <a:prstGeom prst="rect">
+            <a:avLst/>
+          </a:prstGeom>
+        </p:spPr>
+      </p:pic>
     </p:spTree>
   </p:cSld>
   <p:clrMapOvr>
@@ -6121,7 +6145,7 @@
         </p:nvSpPr>
         <p:spPr>
           <a:xfrm>
-            <a:off x="585216" y="1719072"/>
+            <a:off x="585216" y="1399032"/>
             <a:ext cx="50292" cy="182880"/>
           </a:xfrm>
           <a:prstGeom prst="roundRect">
@@ -6165,8 +6189,8 @@
         </p:nvSpPr>
         <p:spPr>
           <a:xfrm>
-            <a:off x="786384" y="1664207"/>
-            <a:ext cx="10222992" cy="365760"/>
+            <a:off x="786384" y="1344168"/>
+            <a:ext cx="3063239" cy="365760"/>
           </a:xfrm>
           <a:prstGeom prst="rect">
             <a:avLst/>
@@ -6186,7 +6210,7 @@
                 </a:solidFill>
                 <a:latin typeface="Helvetica"/>
               </a:rPr>
-              <a:t>**Weeks 1 to 3, track A.** Solis to Tharsis, the exchange that already failed. Calendar and epoch, the aggregation, the derate, the schedule owner, units and encoding. The derate is the expensive one, because it means Solis says publicly how its capacity degrades.</a:t>
+              <a:t>**Track A** is the critical path. The exchange that already failed.</a:t>
             </a:r>
           </a:p>
         </p:txBody>
@@ -6199,7 +6223,7 @@
         </p:nvSpPr>
         <p:spPr>
           <a:xfrm>
-            <a:off x="585216" y="3328416"/>
+            <a:off x="585216" y="2093976"/>
             <a:ext cx="50292" cy="182880"/>
           </a:xfrm>
           <a:prstGeom prst="roundRect">
@@ -6243,8 +6267,8 @@
         </p:nvSpPr>
         <p:spPr>
           <a:xfrm>
-            <a:off x="786384" y="3273552"/>
-            <a:ext cx="10222992" cy="365760"/>
+            <a:off x="786384" y="2039112"/>
+            <a:ext cx="3063239" cy="365760"/>
           </a:xfrm>
           <a:prstGeom prst="rect">
             <a:avLst/>
@@ -6264,7 +6288,7 @@
                 </a:solidFill>
                 <a:latin typeface="Helvetica"/>
               </a:rPr>
-              <a:t>**Weeks 1 to 3, track B.** Meridian's evidence requirement, its thresholds routed to the model that applies them, and the stress event chosen. In parallel, because what it requires changes what track A must carry.</a:t>
+              <a:t>**Track B** runs alongside, because what Meridian requires changes what track A must carry.</a:t>
             </a:r>
           </a:p>
         </p:txBody>
@@ -6277,7 +6301,7 @@
         </p:nvSpPr>
         <p:spPr>
           <a:xfrm>
-            <a:off x="585216" y="4571999"/>
+            <a:off x="585216" y="2971799"/>
             <a:ext cx="50292" cy="182880"/>
           </a:xfrm>
           <a:prstGeom prst="roundRect">
@@ -6321,8 +6345,8 @@
         </p:nvSpPr>
         <p:spPr>
           <a:xfrm>
-            <a:off x="786384" y="4517136"/>
-            <a:ext cx="10222992" cy="365760"/>
+            <a:off x="786384" y="2916935"/>
+            <a:ext cx="3063239" cy="365760"/>
           </a:xfrm>
           <a:prstGeom prst="rect">
             <a:avLst/>
@@ -6342,7 +6366,7 @@
                 </a:solidFill>
                 <a:latin typeface="Helvetica"/>
               </a:rPr>
-              <a:t>**Week 2.** Contract v0, and the skeleton runs.</a:t>
+              <a:t>**Week 2** runs end to end on crude inputs, so integration fails early.</a:t>
             </a:r>
           </a:p>
         </p:txBody>
@@ -6355,7 +6379,7 @@
         </p:nvSpPr>
         <p:spPr>
           <a:xfrm>
-            <a:off x="585216" y="5266943"/>
+            <a:off x="585216" y="3666743"/>
             <a:ext cx="50292" cy="182880"/>
           </a:xfrm>
           <a:prstGeom prst="roundRect">
@@ -6399,8 +6423,8 @@
         </p:nvSpPr>
         <p:spPr>
           <a:xfrm>
-            <a:off x="786384" y="5212079"/>
-            <a:ext cx="10222992" cy="365760"/>
+            <a:off x="786384" y="3611879"/>
+            <a:ext cx="3063239" cy="365760"/>
           </a:xfrm>
           <a:prstGeom prst="rect">
             <a:avLst/>
@@ -6420,7 +6444,7 @@
                 </a:solidFill>
                 <a:latin typeface="Helvetica"/>
               </a:rPr>
-              <a:t>**Weeks 3 and 4.** Normal case, then the stress event run iterated, with the derate taken from shared declared state rather than privately.</a:t>
+              <a:t>**Week 5** is buffer and nothing is scheduled into it that cannot move out.</a:t>
             </a:r>
           </a:p>
         </p:txBody>
@@ -6433,7 +6457,7 @@
         </p:nvSpPr>
         <p:spPr>
           <a:xfrm>
-            <a:off x="585216" y="6327647"/>
+            <a:off x="585216" y="4361687"/>
             <a:ext cx="50292" cy="182880"/>
           </a:xfrm>
           <a:prstGeom prst="roundRect">
@@ -6477,8 +6501,8 @@
         </p:nvSpPr>
         <p:spPr>
           <a:xfrm>
-            <a:off x="786384" y="6272783"/>
-            <a:ext cx="10222992" cy="365760"/>
+            <a:off x="786384" y="4306823"/>
+            <a:ext cx="3063239" cy="365760"/>
           </a:xfrm>
           <a:prstGeom prst="rect">
             <a:avLst/>
@@ -6498,7 +6522,7 @@
                 </a:solidFill>
                 <a:latin typeface="Helvetica"/>
               </a:rPr>
-              <a:t>**Weeks 5 and 6.** Buffer, the traceability pass, then rehearsal. For every number: which model, which contract, which schedule version, which threshold set.</a:t>
+              <a:t>Review points end weeks 1, 2, 3 and 5. Every action closes a named gap.</a:t>
             </a:r>
           </a:p>
         </p:txBody>
@@ -6532,11 +6556,35 @@
                 </a:solidFill>
                 <a:latin typeface="Helvetica"/>
               </a:rPr>
-              <a:t>Review points end weeks 1, 2, 3 and 5. Every action closes a named gap.</a:t>
-            </a:r>
-          </a:p>
-        </p:txBody>
-      </p:sp>
+              <a:t>The traceability pass is the deliverable, not the run.</a:t>
+            </a:r>
+          </a:p>
+        </p:txBody>
+      </p:sp>
+      <p:pic>
+        <p:nvPicPr>
+          <p:cNvPr id="15" name="Picture 14" descr="calendar.png"/>
+          <p:cNvPicPr>
+            <a:picLocks noChangeAspect="1"/>
+          </p:cNvPicPr>
+          <p:nvPr/>
+        </p:nvPicPr>
+        <p:blipFill>
+          <a:blip r:embed="rId2"/>
+          <a:stretch>
+            <a:fillRect/>
+          </a:stretch>
+        </p:blipFill>
+        <p:spPr>
+          <a:xfrm>
+            <a:off x="4169663" y="1344168"/>
+            <a:ext cx="7436815" cy="3962871"/>
+          </a:xfrm>
+          <a:prstGeom prst="rect">
+            <a:avLst/>
+          </a:prstGeom>
+        </p:spPr>
+      </p:pic>
     </p:spTree>
   </p:cSld>
   <p:clrMapOvr>

</xml_diff>

<commit_message>
Drop the slide that described the artifact
Seven core slides plus the cover. The artifact is demonstrated live for three to
five minutes, so a slide describing the thing the panel is about to be shown was
spending a slot on redundancy.

Two things left the deck with it and both have somewhere else to be. The clause
matrix, which is the strongest evidence in the set, and the honest statement of
what the tool cannot tell you. The matrix is regenerated by the artifact itself
on every run, and the limits are set out in docs/ai_use.md, which the brief asks
for in the deck or the appendix and which slide seven still points to.
</commit_message>
<xml_diff>
--- a/deck/ares_board_deck.pptx
+++ b/deck/ares_board_deck.pptx
@@ -13,7 +13,6 @@
     <p:sldId id="261" r:id="rId13"/>
     <p:sldId id="262" r:id="rId14"/>
     <p:sldId id="263" r:id="rId15"/>
-    <p:sldId id="264" r:id="rId16"/>
   </p:sldIdLst>
   <p:sldSz cx="12191695" cy="6858000" type="screen4x3"/>
   <p:notesSz cx="6858000" cy="9144000"/>
@@ -938,77 +937,6 @@
             <a:r>
               <a:rPr sz="1100"/>
               <a:t>A neutral checker reporting that two partners exchange something neither declares makes the gap a property of the interface rather than an accusation.</a:t>
-            </a:r>
-          </a:p>
-        </p:txBody>
-      </p:sp>
-      <p:sp>
-        <p:nvSpPr>
-          <p:cNvPr id="4" name="Slide Number Placeholder 3"/>
-          <p:cNvSpPr>
-            <a:spLocks noGrp="1"/>
-          </p:cNvSpPr>
-          <p:nvPr>
-            <p:ph type="sldNum" idx="5" sz="quarter"/>
-          </p:nvPr>
-        </p:nvSpPr>
-        <p:spPr/>
-      </p:sp>
-    </p:spTree>
-  </p:cSld>
-  <p:clrMapOvr>
-    <a:masterClrMapping/>
-  </p:clrMapOvr>
-</p:notes>
-</file>
-
-<file path=ppt/notesSlides/notesSlide8.xml><?xml version="1.0" encoding="utf-8"?>
-<p:notes xmlns:a="http://schemas.openxmlformats.org/drawingml/2006/main" xmlns:p="http://schemas.openxmlformats.org/presentationml/2006/main" xmlns:r="http://schemas.openxmlformats.org/officeDocument/2006/relationships">
-  <p:cSld>
-    <p:spTree>
-      <p:nvGrpSpPr>
-        <p:cNvPr id="1" name=""/>
-        <p:cNvGrpSpPr/>
-        <p:nvPr/>
-      </p:nvGrpSpPr>
-      <p:grpSpPr>
-        <a:xfrm>
-          <a:off x="0" y="0"/>
-          <a:ext cx="0" cy="0"/>
-          <a:chOff x="0" y="0"/>
-          <a:chExt cx="0" cy="0"/>
-        </a:xfrm>
-      </p:grpSpPr>
-      <p:sp>
-        <p:nvSpPr>
-          <p:cNvPr id="2" name="Slide Image Placeholder 1"/>
-          <p:cNvSpPr>
-            <a:spLocks noGrp="1"/>
-          </p:cNvSpPr>
-          <p:nvPr>
-            <p:ph type="sldImg" idx="2"/>
-          </p:nvPr>
-        </p:nvSpPr>
-        <p:spPr/>
-      </p:sp>
-      <p:sp>
-        <p:nvSpPr>
-          <p:cNvPr id="3" name="Notes Placeholder 2"/>
-          <p:cNvSpPr>
-            <a:spLocks noGrp="1"/>
-          </p:cNvSpPr>
-          <p:nvPr>
-            <p:ph type="body" idx="3" sz="quarter"/>
-          </p:nvPr>
-        </p:nvSpPr>
-        <p:spPr/>
-        <p:txBody>
-          <a:bodyPr/>
-          <a:lstStyle/>
-          <a:p>
-            <a:r>
-              <a:rPr sz="1100"/>
-              <a:t>Demo in three minutes: run it, show the calendar, select an orphaned item, show the finding, open the declaration and read the sentence it came from. Close on the limits. If asked how this position differs from the one that was confidently wrong and overruled mid-session: not by better reasoning, but by naming in advance the result that would overturn it and putting it in week 5.</a:t>
             </a:r>
           </a:p>
         </p:txBody>
@@ -4311,48 +4239,6 @@
       <p:pic>
         <p:nvPicPr>
           <p:cNvPr id="2" name="Picture 1" descr="07.png"/>
-          <p:cNvPicPr>
-            <a:picLocks noChangeAspect="1"/>
-          </p:cNvPicPr>
-          <p:nvPr/>
-        </p:nvPicPr>
-        <p:blipFill>
-          <a:blip r:embed="rId2"/>
-          <a:stretch>
-            <a:fillRect/>
-          </a:stretch>
-        </p:blipFill>
-        <p:spPr>
-          <a:xfrm>
-            <a:off x="0" y="0"/>
-            <a:ext cx="12191695" cy="6858000"/>
-          </a:xfrm>
-          <a:prstGeom prst="rect">
-            <a:avLst/>
-          </a:prstGeom>
-        </p:spPr>
-      </p:pic>
-    </p:spTree>
-  </p:cSld>
-  <p:clrMapOvr>
-    <a:masterClrMapping/>
-  </p:clrMapOvr>
-</p:sld>
-</file>
-
-<file path=ppt/slides/slide9.xml><?xml version="1.0" encoding="utf-8"?>
-<p:sld xmlns:a="http://schemas.openxmlformats.org/drawingml/2006/main" xmlns:p="http://schemas.openxmlformats.org/presentationml/2006/main" xmlns:r="http://schemas.openxmlformats.org/officeDocument/2006/relationships">
-  <p:cSld>
-    <p:spTree>
-      <p:nvGrpSpPr>
-        <p:cNvPr id="1" name=""/>
-        <p:cNvGrpSpPr/>
-        <p:nvPr/>
-      </p:nvGrpSpPr>
-      <p:grpSpPr/>
-      <p:pic>
-        <p:nvPicPr>
-          <p:cNvPr id="2" name="Picture 1" descr="08.png"/>
           <p:cNvPicPr>
             <a:picLocks noChangeAspect="1"/>
           </p:cNvPicPr>

</xml_diff>